<commit_message>
docs: update AITU title pages and supervisor details
Record the supplied academic identity and team-reported hackathon win. Preserve the distinction between reported achievement and documented user interviews.
</commit_message>
<xml_diff>
--- a/docs/diploma/deliverables/Hattama_PreDefense_Presentation.pptx
+++ b/docs/diploma/deliverables/Hattama_PreDefense_Presentation.pptx
@@ -2,34 +2,34 @@
 <file path=ppt/presentation.xml><?xml version="1.0" encoding="utf-8"?>
 <p:presentation xmlns:p="http://schemas.openxmlformats.org/presentationml/2006/main">
   <p:sldMasterIdLst>
-    <p:sldMasterId xmlns:r="http://schemas.openxmlformats.org/officeDocument/2006/relationships" id="2147483648" r:id="R2c7b64049bcc4e65"/>
+    <p:sldMasterId xmlns:r="http://schemas.openxmlformats.org/officeDocument/2006/relationships" id="2147483648" r:id="Rdcfb096bb3e740a1"/>
   </p:sldMasterIdLst>
   <p:notesMasterIdLst>
-    <p:notesMasterId xmlns:r="http://schemas.openxmlformats.org/officeDocument/2006/relationships" r:id="R3f6717830a774de5"/>
+    <p:notesMasterId xmlns:r="http://schemas.openxmlformats.org/officeDocument/2006/relationships" r:id="Rab8133414aa24c99"/>
   </p:notesMasterIdLst>
   <p:sldIdLst>
-    <p:sldId xmlns:r="http://schemas.openxmlformats.org/officeDocument/2006/relationships" id="256" r:id="R592dd577fff94f51"/>
-    <p:sldId xmlns:r="http://schemas.openxmlformats.org/officeDocument/2006/relationships" id="257" r:id="R6781c1c7f78e4dcb"/>
-    <p:sldId xmlns:r="http://schemas.openxmlformats.org/officeDocument/2006/relationships" id="258" r:id="R899d3e4648a8476f"/>
-    <p:sldId xmlns:r="http://schemas.openxmlformats.org/officeDocument/2006/relationships" id="259" r:id="Rb91d02d1e7bc46da"/>
-    <p:sldId xmlns:r="http://schemas.openxmlformats.org/officeDocument/2006/relationships" id="260" r:id="Rfc520b37403a4524"/>
-    <p:sldId xmlns:r="http://schemas.openxmlformats.org/officeDocument/2006/relationships" id="261" r:id="Rdcaefd429c9e4a09"/>
-    <p:sldId xmlns:r="http://schemas.openxmlformats.org/officeDocument/2006/relationships" id="262" r:id="R0c6d1f87eeff4cf4"/>
-    <p:sldId xmlns:r="http://schemas.openxmlformats.org/officeDocument/2006/relationships" id="263" r:id="R15c3f896f74e4f81"/>
-    <p:sldId xmlns:r="http://schemas.openxmlformats.org/officeDocument/2006/relationships" id="264" r:id="R286839ec3bc0468c"/>
-    <p:sldId xmlns:r="http://schemas.openxmlformats.org/officeDocument/2006/relationships" id="265" r:id="R4cc2289a0e7f4981"/>
-    <p:sldId xmlns:r="http://schemas.openxmlformats.org/officeDocument/2006/relationships" id="266" r:id="Rfda0c42754324ffc"/>
-    <p:sldId xmlns:r="http://schemas.openxmlformats.org/officeDocument/2006/relationships" id="267" r:id="R38c2e144ae254d98"/>
-    <p:sldId xmlns:r="http://schemas.openxmlformats.org/officeDocument/2006/relationships" id="268" r:id="R2b918b90e74f47c9"/>
-    <p:sldId xmlns:r="http://schemas.openxmlformats.org/officeDocument/2006/relationships" id="269" r:id="R6408798cc9634606"/>
-    <p:sldId xmlns:r="http://schemas.openxmlformats.org/officeDocument/2006/relationships" id="270" r:id="R3c97743c275f410d"/>
-    <p:sldId xmlns:r="http://schemas.openxmlformats.org/officeDocument/2006/relationships" id="271" r:id="Rdf176c8493244ca8"/>
-    <p:sldId xmlns:r="http://schemas.openxmlformats.org/officeDocument/2006/relationships" id="272" r:id="R4843e714a3214da0"/>
-    <p:sldId xmlns:r="http://schemas.openxmlformats.org/officeDocument/2006/relationships" id="273" r:id="R836c195132ad4ee8"/>
-    <p:sldId xmlns:r="http://schemas.openxmlformats.org/officeDocument/2006/relationships" id="274" r:id="R960932da54a44417"/>
-    <p:sldId xmlns:r="http://schemas.openxmlformats.org/officeDocument/2006/relationships" id="275" r:id="Rb20c2cbc6b704c80"/>
-    <p:sldId xmlns:r="http://schemas.openxmlformats.org/officeDocument/2006/relationships" id="276" r:id="Rbd25a72c2029448f"/>
-    <p:sldId xmlns:r="http://schemas.openxmlformats.org/officeDocument/2006/relationships" id="277" r:id="Rec85cf0e27104d39"/>
+    <p:sldId xmlns:r="http://schemas.openxmlformats.org/officeDocument/2006/relationships" id="256" r:id="R9ea078c337cd4106"/>
+    <p:sldId xmlns:r="http://schemas.openxmlformats.org/officeDocument/2006/relationships" id="257" r:id="R1d0e2542b5d74140"/>
+    <p:sldId xmlns:r="http://schemas.openxmlformats.org/officeDocument/2006/relationships" id="258" r:id="Rc70a8daeaf894a86"/>
+    <p:sldId xmlns:r="http://schemas.openxmlformats.org/officeDocument/2006/relationships" id="259" r:id="R5f500fdd61af4bd5"/>
+    <p:sldId xmlns:r="http://schemas.openxmlformats.org/officeDocument/2006/relationships" id="260" r:id="R995f90c500c541b5"/>
+    <p:sldId xmlns:r="http://schemas.openxmlformats.org/officeDocument/2006/relationships" id="261" r:id="R5d56ef14bdb94d50"/>
+    <p:sldId xmlns:r="http://schemas.openxmlformats.org/officeDocument/2006/relationships" id="262" r:id="R74a88116d02e4880"/>
+    <p:sldId xmlns:r="http://schemas.openxmlformats.org/officeDocument/2006/relationships" id="263" r:id="R1d7200e916824af8"/>
+    <p:sldId xmlns:r="http://schemas.openxmlformats.org/officeDocument/2006/relationships" id="264" r:id="Rdc01f94023e94fd1"/>
+    <p:sldId xmlns:r="http://schemas.openxmlformats.org/officeDocument/2006/relationships" id="265" r:id="Rae6da42af8b74b94"/>
+    <p:sldId xmlns:r="http://schemas.openxmlformats.org/officeDocument/2006/relationships" id="266" r:id="R51fc46c2bb174d41"/>
+    <p:sldId xmlns:r="http://schemas.openxmlformats.org/officeDocument/2006/relationships" id="267" r:id="Rd1aa8fe46b194335"/>
+    <p:sldId xmlns:r="http://schemas.openxmlformats.org/officeDocument/2006/relationships" id="268" r:id="R5c823667e9484db5"/>
+    <p:sldId xmlns:r="http://schemas.openxmlformats.org/officeDocument/2006/relationships" id="269" r:id="R717c82d839ce4834"/>
+    <p:sldId xmlns:r="http://schemas.openxmlformats.org/officeDocument/2006/relationships" id="270" r:id="Rcae8dca67cbc404a"/>
+    <p:sldId xmlns:r="http://schemas.openxmlformats.org/officeDocument/2006/relationships" id="271" r:id="Racab2d86f8f6495f"/>
+    <p:sldId xmlns:r="http://schemas.openxmlformats.org/officeDocument/2006/relationships" id="272" r:id="R7b353073c29b4aa9"/>
+    <p:sldId xmlns:r="http://schemas.openxmlformats.org/officeDocument/2006/relationships" id="273" r:id="R62f69ae0bf734b98"/>
+    <p:sldId xmlns:r="http://schemas.openxmlformats.org/officeDocument/2006/relationships" id="274" r:id="R34b7ceb6ed5f4170"/>
+    <p:sldId xmlns:r="http://schemas.openxmlformats.org/officeDocument/2006/relationships" id="275" r:id="R44c7ad4743574554"/>
+    <p:sldId xmlns:r="http://schemas.openxmlformats.org/officeDocument/2006/relationships" id="276" r:id="R6af5461ddaff437a"/>
+    <p:sldId xmlns:r="http://schemas.openxmlformats.org/officeDocument/2006/relationships" id="277" r:id="Rc278e67886c84cb2"/>
   </p:sldIdLst>
   <p:sldSz cx="12192000" cy="6858000"/>
   <p:notesSz cx="6858000" cy="9144000"/>
@@ -1758,7 +1758,7 @@
           <a:lstStyle xmlns:a="http://schemas.openxmlformats.org/drawingml/2006/main"/>
           <a:p xmlns:a="http://schemas.openxmlformats.org/drawingml/2006/main">
             <a:r>
-              <a:t>Published evidence is secondary research. Constructed scenarios in the report illustrate requirements and are not actual interviews. The rubric still requests 3–5 user discussions or a substantive client agreement unless a supervisor-approved alternative is accepted.</a:t>
+              <a:t>The team reports winning a hackathon with Hattama; event details and an award reference are pending. Published evidence is secondary research. Constructed scenarios in the report illustrate requirements and are not actual interviews. The rubric still requests 3–5 user discussions or a substantive client agreement unless a supervisor-approved alternative is accepted.</a:t>
             </a:r>
           </a:p>
           <a:p xmlns:a="http://schemas.openxmlformats.org/drawingml/2006/main">
@@ -2406,7 +2406,7 @@
   </p:cSld>
   <p:clrMap bg1="lt1" tx1="dk1" bg2="lt2" tx2="dk2" accent1="accent1" accent2="accent2" accent3="accent3" accent4="accent4" accent5="accent5" accent6="accent6" hlink="hlink" folHlink="folHlink"/>
   <p:sldLayoutIdLst>
-    <p:sldLayoutId xmlns:r="http://schemas.openxmlformats.org/officeDocument/2006/relationships" id="2147483649" r:id="R627c6ef3877549fb"/>
+    <p:sldLayoutId xmlns:r="http://schemas.openxmlformats.org/officeDocument/2006/relationships" id="2147483649" r:id="Rf455a0fc278d414f"/>
   </p:sldLayoutIdLst>
   <p:txStyles>
     <p:titleStyle>
@@ -3084,8 +3084,8 @@
         </p:nvSpPr>
         <p:spPr>
           <a:xfrm xmlns:a="http://schemas.openxmlformats.org/drawingml/2006/main">
-            <a:off x="628650" y="1714500"/>
-            <a:ext cx="10668000" cy="2095500"/>
+            <a:off x="628650" y="1428750"/>
+            <a:ext cx="10668000" cy="619125"/>
           </a:xfrm>
           <a:prstGeom xmlns:a="http://schemas.openxmlformats.org/drawingml/2006/main" prst="rect">
             <a:avLst/>
@@ -3103,9 +3103,9 @@
           <a:p xmlns:a="http://schemas.openxmlformats.org/drawingml/2006/main">
             <a:pPr>
               <a:buNone/>
-              <a:defRPr sz="3150" b="0">
-                <a:solidFill>
-                  <a:srgbClr val="183D34"/>
+              <a:defRPr sz="1800" b="0">
+                <a:solidFill>
+                  <a:srgbClr val="5D7167"/>
                 </a:solidFill>
                 <a:latin typeface="Arial"/>
                 <a:ea typeface="Arial"/>
@@ -3113,23 +3113,23 @@
               </a:defRPr>
             </a:pPr>
             <a:r>
-              <a:rPr sz="3150" b="0">
-                <a:solidFill>
-                  <a:srgbClr val="183D34"/>
+              <a:rPr sz="1800" b="0">
+                <a:solidFill>
+                  <a:srgbClr val="5D7167"/>
                 </a:solidFill>
                 <a:latin typeface="Arial"/>
                 <a:ea typeface="Arial"/>
                 <a:cs typeface="Arial"/>
               </a:rPr>
-              <a:t>Development of a Platform for Automated</a:t>
+              <a:t>Astana IT University</a:t>
             </a:r>
           </a:p>
           <a:p xmlns:a="http://schemas.openxmlformats.org/drawingml/2006/main">
             <a:pPr>
               <a:buNone/>
-              <a:defRPr sz="3150" b="0">
-                <a:solidFill>
-                  <a:srgbClr val="183D34"/>
+              <a:defRPr sz="1800" b="0">
+                <a:solidFill>
+                  <a:srgbClr val="5D7167"/>
                 </a:solidFill>
                 <a:latin typeface="Arial"/>
                 <a:ea typeface="Arial"/>
@@ -3137,39 +3137,15 @@
               </a:defRPr>
             </a:pPr>
             <a:r>
-              <a:rPr sz="3150" b="0">
-                <a:solidFill>
-                  <a:srgbClr val="183D34"/>
+              <a:rPr sz="1800" b="0">
+                <a:solidFill>
+                  <a:srgbClr val="5D7167"/>
                 </a:solidFill>
                 <a:latin typeface="Arial"/>
                 <a:ea typeface="Arial"/>
                 <a:cs typeface="Arial"/>
               </a:rPr>
-              <a:t>Meeting Minutes Generation in Kazakh and</a:t>
-            </a:r>
-          </a:p>
-          <a:p xmlns:a="http://schemas.openxmlformats.org/drawingml/2006/main">
-            <a:pPr>
-              <a:buNone/>
-              <a:defRPr sz="3150" b="0">
-                <a:solidFill>
-                  <a:srgbClr val="183D34"/>
-                </a:solidFill>
-                <a:latin typeface="Arial"/>
-                <a:ea typeface="Arial"/>
-                <a:cs typeface="Arial"/>
-              </a:defRPr>
-            </a:pPr>
-            <a:r>
-              <a:rPr sz="3150" b="0">
-                <a:solidFill>
-                  <a:srgbClr val="183D34"/>
-                </a:solidFill>
-                <a:latin typeface="Arial"/>
-                <a:ea typeface="Arial"/>
-                <a:cs typeface="Arial"/>
-              </a:rPr>
-              <a:t>Russian Using Neural Network Models</a:t>
+              <a:t>School of Software Engineering</a:t>
             </a:r>
           </a:p>
         </p:txBody>
@@ -3190,8 +3166,8 @@
         </p:nvSpPr>
         <p:spPr>
           <a:xfrm xmlns:a="http://schemas.openxmlformats.org/drawingml/2006/main">
-            <a:off x="628650" y="4429125"/>
-            <a:ext cx="10668000" cy="428625"/>
+            <a:off x="628650" y="2333625"/>
+            <a:ext cx="10668000" cy="1666875"/>
           </a:xfrm>
           <a:prstGeom xmlns:a="http://schemas.openxmlformats.org/drawingml/2006/main" prst="rect">
             <a:avLst/>
@@ -3209,7 +3185,7 @@
           <a:p xmlns:a="http://schemas.openxmlformats.org/drawingml/2006/main">
             <a:pPr>
               <a:buNone/>
-              <a:defRPr sz="1875" b="0">
+              <a:defRPr sz="2700" b="0">
                 <a:solidFill>
                   <a:srgbClr val="183D34"/>
                 </a:solidFill>
@@ -3219,7 +3195,7 @@
               </a:defRPr>
             </a:pPr>
             <a:r>
-              <a:rPr sz="1875" b="0">
+              <a:rPr sz="2700" b="0">
                 <a:solidFill>
                   <a:srgbClr val="183D34"/>
                 </a:solidFill>
@@ -3227,7 +3203,55 @@
                 <a:ea typeface="Arial"/>
                 <a:cs typeface="Arial"/>
               </a:rPr>
-              <a:t>Akhmetov Kazbek  /  Uranov Daryn  /  Tazhibayev Marsel</a:t>
+              <a:t>Development of a Platform for Automated</a:t>
+            </a:r>
+          </a:p>
+          <a:p xmlns:a="http://schemas.openxmlformats.org/drawingml/2006/main">
+            <a:pPr>
+              <a:buNone/>
+              <a:defRPr sz="2700" b="0">
+                <a:solidFill>
+                  <a:srgbClr val="183D34"/>
+                </a:solidFill>
+                <a:latin typeface="Arial"/>
+                <a:ea typeface="Arial"/>
+                <a:cs typeface="Arial"/>
+              </a:defRPr>
+            </a:pPr>
+            <a:r>
+              <a:rPr sz="2700" b="0">
+                <a:solidFill>
+                  <a:srgbClr val="183D34"/>
+                </a:solidFill>
+                <a:latin typeface="Arial"/>
+                <a:ea typeface="Arial"/>
+                <a:cs typeface="Arial"/>
+              </a:rPr>
+              <a:t>Meeting Minutes Generation in Kazakh and</a:t>
+            </a:r>
+          </a:p>
+          <a:p xmlns:a="http://schemas.openxmlformats.org/drawingml/2006/main">
+            <a:pPr>
+              <a:buNone/>
+              <a:defRPr sz="2700" b="0">
+                <a:solidFill>
+                  <a:srgbClr val="183D34"/>
+                </a:solidFill>
+                <a:latin typeface="Arial"/>
+                <a:ea typeface="Arial"/>
+                <a:cs typeface="Arial"/>
+              </a:defRPr>
+            </a:pPr>
+            <a:r>
+              <a:rPr sz="2700" b="0">
+                <a:solidFill>
+                  <a:srgbClr val="183D34"/>
+                </a:solidFill>
+                <a:latin typeface="Arial"/>
+                <a:ea typeface="Arial"/>
+                <a:cs typeface="Arial"/>
+              </a:rPr>
+              <a:t>Russian Using Neural Network Models</a:t>
             </a:r>
           </a:p>
         </p:txBody>
@@ -3248,8 +3272,8 @@
         </p:nvSpPr>
         <p:spPr>
           <a:xfrm xmlns:a="http://schemas.openxmlformats.org/drawingml/2006/main">
-            <a:off x="628650" y="5143500"/>
-            <a:ext cx="10668000" cy="714375"/>
+            <a:off x="628650" y="4286250"/>
+            <a:ext cx="10668000" cy="666750"/>
           </a:xfrm>
           <a:prstGeom xmlns:a="http://schemas.openxmlformats.org/drawingml/2006/main" prst="rect">
             <a:avLst/>
@@ -3269,7 +3293,7 @@
               <a:buNone/>
               <a:defRPr sz="1725" b="0">
                 <a:solidFill>
-                  <a:srgbClr val="5D7167"/>
+                  <a:srgbClr val="183D34"/>
                 </a:solidFill>
                 <a:latin typeface="Arial"/>
                 <a:ea typeface="Arial"/>
@@ -3279,13 +3303,13 @@
             <a:r>
               <a:rPr sz="1725" b="0">
                 <a:solidFill>
-                  <a:srgbClr val="5D7167"/>
+                  <a:srgbClr val="183D34"/>
                 </a:solidFill>
                 <a:latin typeface="Arial"/>
                 <a:ea typeface="Arial"/>
                 <a:cs typeface="Arial"/>
               </a:rPr>
-              <a:t>Supervisor: Elvira Aitmukhambetovna</a:t>
+              <a:t>Akhmetov Kazbek  /  Uranov Daryn  /  Tazhibayev Marsel</a:t>
             </a:r>
           </a:p>
           <a:p xmlns:a="http://schemas.openxmlformats.org/drawingml/2006/main">
@@ -3293,7 +3317,7 @@
               <a:buNone/>
               <a:defRPr sz="1725" b="0">
                 <a:solidFill>
-                  <a:srgbClr val="5D7167"/>
+                  <a:srgbClr val="183D34"/>
                 </a:solidFill>
                 <a:latin typeface="Arial"/>
                 <a:ea typeface="Arial"/>
@@ -3303,13 +3327,93 @@
             <a:r>
               <a:rPr sz="1725" b="0">
                 <a:solidFill>
+                  <a:srgbClr val="183D34"/>
+                </a:solidFill>
+                <a:latin typeface="Arial"/>
+                <a:ea typeface="Arial"/>
+                <a:cs typeface="Arial"/>
+              </a:rPr>
+              <a:t>Software Engineering  /  SE-2403</a:t>
+            </a:r>
+          </a:p>
+        </p:txBody>
+      </p:sp>
+      <p:sp>
+        <p:nvSpPr>
+          <p:cNvPr id="7" name="">
+            <a:extLst xmlns:a="http://schemas.openxmlformats.org/drawingml/2006/main">
+              <a:ext uri="{FF2B5EF4-FFF2-40B4-BE49-F238E27FC236}">
+                <a16:creationId xmlns:a16="http://schemas.microsoft.com/office/drawing/2014/main" id="{BAAC5861-27DC-4078-8131-7BF021112470}"/>
+              </a:ext>
+            </a:extLst>
+          </p:cNvPr>
+          <p:cNvSpPr>
+            <a:spLocks xmlns:a="http://schemas.openxmlformats.org/drawingml/2006/main" noGrp="1"/>
+          </p:cNvSpPr>
+          <p:nvPr/>
+        </p:nvSpPr>
+        <p:spPr>
+          <a:xfrm xmlns:a="http://schemas.openxmlformats.org/drawingml/2006/main">
+            <a:off x="628650" y="5286375"/>
+            <a:ext cx="10668000" cy="619125"/>
+          </a:xfrm>
+          <a:prstGeom xmlns:a="http://schemas.openxmlformats.org/drawingml/2006/main" prst="rect">
+            <a:avLst/>
+          </a:prstGeom>
+          <a:noFill xmlns:a="http://schemas.openxmlformats.org/drawingml/2006/main"/>
+          <a:ln xmlns:a="http://schemas.openxmlformats.org/drawingml/2006/main" w="0">
+            <a:noFill/>
+          </a:ln>
+        </p:spPr>
+        <p:txBody>
+          <a:bodyPr xmlns:a="http://schemas.openxmlformats.org/drawingml/2006/main">
+            <a:noAutofit/>
+          </a:bodyPr>
+          <a:lstStyle xmlns:a="http://schemas.openxmlformats.org/drawingml/2006/main"/>
+          <a:p xmlns:a="http://schemas.openxmlformats.org/drawingml/2006/main">
+            <a:pPr>
+              <a:defRPr sz="1650" b="0">
+                <a:solidFill>
                   <a:srgbClr val="5D7167"/>
                 </a:solidFill>
                 <a:latin typeface="Arial"/>
                 <a:ea typeface="Arial"/>
                 <a:cs typeface="Arial"/>
+              </a:defRPr>
+            </a:pPr>
+            <a:r>
+              <a:rPr sz="1650" b="0">
+                <a:solidFill>
+                  <a:srgbClr val="5D7167"/>
+                </a:solidFill>
+                <a:latin typeface="Arial"/>
+                <a:ea typeface="Arial"/>
+                <a:cs typeface="Arial"/>
               </a:rPr>
-              <a:t>First pre-defense preparation · 23 October 2026</a:t>
+              <a:t>Supervisor: Aitmukhanbetova Elvira, Senior Lecturer</a:t>
+            </a:r>
+          </a:p>
+          <a:p xmlns:a="http://schemas.openxmlformats.org/drawingml/2006/main">
+            <a:pPr>
+              <a:defRPr sz="1650" b="0">
+                <a:solidFill>
+                  <a:srgbClr val="5D7167"/>
+                </a:solidFill>
+                <a:latin typeface="Arial"/>
+                <a:ea typeface="Arial"/>
+                <a:cs typeface="Arial"/>
+              </a:defRPr>
+            </a:pPr>
+            <a:r>
+              <a:rPr sz="1650" b="0">
+                <a:solidFill>
+                  <a:srgbClr val="5D7167"/>
+                </a:solidFill>
+                <a:latin typeface="Arial"/>
+                <a:ea typeface="Arial"/>
+                <a:cs typeface="Arial"/>
+              </a:rPr>
+              <a:t>First pre-defense  /  2026</a:t>
             </a:r>
           </a:p>
         </p:txBody>
@@ -4532,7 +4636,7 @@
           <p:cNvPr id="16" name="">
             <a:extLst xmlns:a="http://schemas.openxmlformats.org/drawingml/2006/main">
               <a:ext uri="{FF2B5EF4-FFF2-40B4-BE49-F238E27FC236}">
-                <a16:creationId xmlns:a16="http://schemas.microsoft.com/office/drawing/2014/main" id="{AC781364-65D0-4F52-8B0E-6114A6F976EC}"/>
+                <a16:creationId xmlns:a16="http://schemas.microsoft.com/office/drawing/2014/main" id="{BD376C09-2A0D-4917-A1C1-EC1CE34D2C78}"/>
               </a:ext>
             </a:extLst>
           </p:cNvPr>
@@ -4593,7 +4697,7 @@
           <p:cNvPr id="17" name="">
             <a:extLst xmlns:a="http://schemas.openxmlformats.org/drawingml/2006/main">
               <a:ext uri="{FF2B5EF4-FFF2-40B4-BE49-F238E27FC236}">
-                <a16:creationId xmlns:a16="http://schemas.microsoft.com/office/drawing/2014/main" id="{E74C2539-3D7D-4216-B975-AE352F0CA489}"/>
+                <a16:creationId xmlns:a16="http://schemas.microsoft.com/office/drawing/2014/main" id="{37C46027-46CC-4287-B12D-53CF8661E9D6}"/>
               </a:ext>
             </a:extLst>
           </p:cNvPr>
@@ -4700,7 +4804,7 @@
           <p:cNvPr id="18" name="">
             <a:extLst xmlns:a="http://schemas.openxmlformats.org/drawingml/2006/main">
               <a:ext uri="{FF2B5EF4-FFF2-40B4-BE49-F238E27FC236}">
-                <a16:creationId xmlns:a16="http://schemas.microsoft.com/office/drawing/2014/main" id="{6FF2D3F0-633A-4117-B8C8-158945BF1546}"/>
+                <a16:creationId xmlns:a16="http://schemas.microsoft.com/office/drawing/2014/main" id="{044418A7-DD79-4FF1-B18B-A6EF6BE7002C}"/>
               </a:ext>
             </a:extLst>
           </p:cNvPr>
@@ -4761,7 +4865,7 @@
           <p:cNvPr id="19" name="">
             <a:extLst xmlns:a="http://schemas.openxmlformats.org/drawingml/2006/main">
               <a:ext uri="{FF2B5EF4-FFF2-40B4-BE49-F238E27FC236}">
-                <a16:creationId xmlns:a16="http://schemas.microsoft.com/office/drawing/2014/main" id="{B3E5EC44-5F80-4B93-AA0D-504C9404EF5E}"/>
+                <a16:creationId xmlns:a16="http://schemas.microsoft.com/office/drawing/2014/main" id="{B3A48443-0182-44C6-BBAD-8B7FDF130513}"/>
               </a:ext>
             </a:extLst>
           </p:cNvPr>
@@ -4920,7 +5024,7 @@
           <p:cNvPr id="23" name="">
             <a:extLst xmlns:a="http://schemas.openxmlformats.org/drawingml/2006/main">
               <a:ext uri="{FF2B5EF4-FFF2-40B4-BE49-F238E27FC236}">
-                <a16:creationId xmlns:a16="http://schemas.microsoft.com/office/drawing/2014/main" id="{86A45527-C0D4-4EB9-82E8-B27AA9BCF24B}"/>
+                <a16:creationId xmlns:a16="http://schemas.microsoft.com/office/drawing/2014/main" id="{56576112-1543-445A-8930-D8065F40EB7C}"/>
               </a:ext>
             </a:extLst>
           </p:cNvPr>
@@ -5122,7 +5226,7 @@
           <p:cNvPr id="19" name="">
             <a:extLst xmlns:a="http://schemas.openxmlformats.org/drawingml/2006/main">
               <a:ext uri="{FF2B5EF4-FFF2-40B4-BE49-F238E27FC236}">
-                <a16:creationId xmlns:a16="http://schemas.microsoft.com/office/drawing/2014/main" id="{C42EEE17-CF60-477F-886E-8703936BF6FD}"/>
+                <a16:creationId xmlns:a16="http://schemas.microsoft.com/office/drawing/2014/main" id="{ACC77A86-24EB-48C1-93FB-AA1B0A75EB21}"/>
               </a:ext>
             </a:extLst>
           </p:cNvPr>
@@ -5183,7 +5287,7 @@
           <p:cNvPr id="20" name="">
             <a:extLst xmlns:a="http://schemas.openxmlformats.org/drawingml/2006/main">
               <a:ext uri="{FF2B5EF4-FFF2-40B4-BE49-F238E27FC236}">
-                <a16:creationId xmlns:a16="http://schemas.microsoft.com/office/drawing/2014/main" id="{4F899B96-0A8F-46CD-8CC7-D6A901DD625C}"/>
+                <a16:creationId xmlns:a16="http://schemas.microsoft.com/office/drawing/2014/main" id="{7CCCD635-F464-4241-A689-32249AC63CFA}"/>
               </a:ext>
             </a:extLst>
           </p:cNvPr>
@@ -5244,7 +5348,7 @@
           <p:cNvPr id="21" name="">
             <a:extLst xmlns:a="http://schemas.openxmlformats.org/drawingml/2006/main">
               <a:ext uri="{FF2B5EF4-FFF2-40B4-BE49-F238E27FC236}">
-                <a16:creationId xmlns:a16="http://schemas.microsoft.com/office/drawing/2014/main" id="{6A10FD1D-F8E0-4CAF-A074-FE44A3A70906}"/>
+                <a16:creationId xmlns:a16="http://schemas.microsoft.com/office/drawing/2014/main" id="{162B295F-BCCB-4DFA-9D34-990DC4763527}"/>
               </a:ext>
             </a:extLst>
           </p:cNvPr>
@@ -5305,7 +5409,7 @@
           <p:cNvPr id="22" name="">
             <a:extLst xmlns:a="http://schemas.openxmlformats.org/drawingml/2006/main">
               <a:ext uri="{FF2B5EF4-FFF2-40B4-BE49-F238E27FC236}">
-                <a16:creationId xmlns:a16="http://schemas.microsoft.com/office/drawing/2014/main" id="{7C0850CB-C883-4C2B-A222-54D7731FF2BB}"/>
+                <a16:creationId xmlns:a16="http://schemas.microsoft.com/office/drawing/2014/main" id="{D2FC29E9-2EFB-42BC-B4CF-08E286017DDE}"/>
               </a:ext>
             </a:extLst>
           </p:cNvPr>
@@ -5366,7 +5470,7 @@
           <p:cNvPr id="23" name="">
             <a:extLst xmlns:a="http://schemas.openxmlformats.org/drawingml/2006/main">
               <a:ext uri="{FF2B5EF4-FFF2-40B4-BE49-F238E27FC236}">
-                <a16:creationId xmlns:a16="http://schemas.microsoft.com/office/drawing/2014/main" id="{0124F260-9882-474E-A90D-3CB599C5BC6D}"/>
+                <a16:creationId xmlns:a16="http://schemas.microsoft.com/office/drawing/2014/main" id="{A41D2927-9C84-4452-B478-DD1895F3FABE}"/>
               </a:ext>
             </a:extLst>
           </p:cNvPr>
@@ -5427,7 +5531,7 @@
           <p:cNvPr id="24" name="">
             <a:extLst xmlns:a="http://schemas.openxmlformats.org/drawingml/2006/main">
               <a:ext uri="{FF2B5EF4-FFF2-40B4-BE49-F238E27FC236}">
-                <a16:creationId xmlns:a16="http://schemas.microsoft.com/office/drawing/2014/main" id="{287C6A27-3C36-4FD8-B6DC-F681F2B8A2F0}"/>
+                <a16:creationId xmlns:a16="http://schemas.microsoft.com/office/drawing/2014/main" id="{CCEF1801-CC74-48E7-A055-815AD0B8E6A5}"/>
               </a:ext>
             </a:extLst>
           </p:cNvPr>
@@ -5488,7 +5592,7 @@
           <p:cNvPr id="25" name="">
             <a:extLst xmlns:a="http://schemas.openxmlformats.org/drawingml/2006/main">
               <a:ext uri="{FF2B5EF4-FFF2-40B4-BE49-F238E27FC236}">
-                <a16:creationId xmlns:a16="http://schemas.microsoft.com/office/drawing/2014/main" id="{60C66801-E1FD-4066-8BB0-2BD0067B5208}"/>
+                <a16:creationId xmlns:a16="http://schemas.microsoft.com/office/drawing/2014/main" id="{BD282AC2-E599-45CA-9AFB-F45A92D492D1}"/>
               </a:ext>
             </a:extLst>
           </p:cNvPr>
@@ -5699,7 +5803,7 @@
           <p:cNvPr id="32" name="">
             <a:extLst xmlns:a="http://schemas.openxmlformats.org/drawingml/2006/main">
               <a:ext uri="{FF2B5EF4-FFF2-40B4-BE49-F238E27FC236}">
-                <a16:creationId xmlns:a16="http://schemas.microsoft.com/office/drawing/2014/main" id="{CB3ABCAB-0F24-4D2C-AC31-56E70644A9D8}"/>
+                <a16:creationId xmlns:a16="http://schemas.microsoft.com/office/drawing/2014/main" id="{3901E100-CB59-4926-B97B-AB094D0CDF89}"/>
               </a:ext>
             </a:extLst>
           </p:cNvPr>
@@ -5901,7 +6005,7 @@
           <p:cNvPr id="18" name="">
             <a:extLst xmlns:a="http://schemas.openxmlformats.org/drawingml/2006/main">
               <a:ext uri="{FF2B5EF4-FFF2-40B4-BE49-F238E27FC236}">
-                <a16:creationId xmlns:a16="http://schemas.microsoft.com/office/drawing/2014/main" id="{94CE534E-7E21-4FA9-9D3F-9F5664DDF536}"/>
+                <a16:creationId xmlns:a16="http://schemas.microsoft.com/office/drawing/2014/main" id="{A80F862F-0F8C-4C7D-89C8-CD3A6934D784}"/>
               </a:ext>
             </a:extLst>
           </p:cNvPr>
@@ -5962,7 +6066,7 @@
           <p:cNvPr id="19" name="">
             <a:extLst xmlns:a="http://schemas.openxmlformats.org/drawingml/2006/main">
               <a:ext uri="{FF2B5EF4-FFF2-40B4-BE49-F238E27FC236}">
-                <a16:creationId xmlns:a16="http://schemas.microsoft.com/office/drawing/2014/main" id="{A2BAE143-3C93-425E-AF06-7B4389154815}"/>
+                <a16:creationId xmlns:a16="http://schemas.microsoft.com/office/drawing/2014/main" id="{1E5D35E4-6F61-4F27-9DF0-B1B3AF35B3BD}"/>
               </a:ext>
             </a:extLst>
           </p:cNvPr>
@@ -6023,7 +6127,7 @@
           <p:cNvPr id="20" name="">
             <a:extLst xmlns:a="http://schemas.openxmlformats.org/drawingml/2006/main">
               <a:ext uri="{FF2B5EF4-FFF2-40B4-BE49-F238E27FC236}">
-                <a16:creationId xmlns:a16="http://schemas.microsoft.com/office/drawing/2014/main" id="{AFCEAC90-D9F3-4815-AEA8-5F1D0FA53644}"/>
+                <a16:creationId xmlns:a16="http://schemas.microsoft.com/office/drawing/2014/main" id="{9260246E-7A23-4FEA-9B4E-7C652CCBAE00}"/>
               </a:ext>
             </a:extLst>
           </p:cNvPr>
@@ -6084,7 +6188,7 @@
           <p:cNvPr id="21" name="">
             <a:extLst xmlns:a="http://schemas.openxmlformats.org/drawingml/2006/main">
               <a:ext uri="{FF2B5EF4-FFF2-40B4-BE49-F238E27FC236}">
-                <a16:creationId xmlns:a16="http://schemas.microsoft.com/office/drawing/2014/main" id="{EF378567-F116-40F5-A502-78CCFEFB3319}"/>
+                <a16:creationId xmlns:a16="http://schemas.microsoft.com/office/drawing/2014/main" id="{B9CE767A-9ADD-4C4D-9622-5C873E26CFC5}"/>
               </a:ext>
             </a:extLst>
           </p:cNvPr>
@@ -6168,7 +6272,7 @@
           <p:cNvPr id="22" name="">
             <a:extLst xmlns:a="http://schemas.openxmlformats.org/drawingml/2006/main">
               <a:ext uri="{FF2B5EF4-FFF2-40B4-BE49-F238E27FC236}">
-                <a16:creationId xmlns:a16="http://schemas.microsoft.com/office/drawing/2014/main" id="{3F61BDFE-2AE1-4695-8534-89855A44C504}"/>
+                <a16:creationId xmlns:a16="http://schemas.microsoft.com/office/drawing/2014/main" id="{F71830AB-DF8D-41D6-A05B-423E284285A3}"/>
               </a:ext>
             </a:extLst>
           </p:cNvPr>
@@ -6229,7 +6333,7 @@
           <p:cNvPr id="23" name="">
             <a:extLst xmlns:a="http://schemas.openxmlformats.org/drawingml/2006/main">
               <a:ext uri="{FF2B5EF4-FFF2-40B4-BE49-F238E27FC236}">
-                <a16:creationId xmlns:a16="http://schemas.microsoft.com/office/drawing/2014/main" id="{01C9990B-C4CF-442F-BAD5-BB427D56946D}"/>
+                <a16:creationId xmlns:a16="http://schemas.microsoft.com/office/drawing/2014/main" id="{ED1B93AB-3B67-42E2-9EDD-D3495162272C}"/>
               </a:ext>
             </a:extLst>
           </p:cNvPr>
@@ -6486,7 +6590,7 @@
           <p:cNvPr id="30" name="">
             <a:extLst xmlns:a="http://schemas.openxmlformats.org/drawingml/2006/main">
               <a:ext uri="{FF2B5EF4-FFF2-40B4-BE49-F238E27FC236}">
-                <a16:creationId xmlns:a16="http://schemas.microsoft.com/office/drawing/2014/main" id="{F3E0048C-4373-4B4A-B98C-FA2C1614A202}"/>
+                <a16:creationId xmlns:a16="http://schemas.microsoft.com/office/drawing/2014/main" id="{01C2A8D0-B18D-4AB9-8BBA-7D4769544F27}"/>
               </a:ext>
             </a:extLst>
           </p:cNvPr>
@@ -6688,7 +6792,7 @@
           <p:cNvPr id="15" name="">
             <a:extLst xmlns:a="http://schemas.openxmlformats.org/drawingml/2006/main">
               <a:ext uri="{FF2B5EF4-FFF2-40B4-BE49-F238E27FC236}">
-                <a16:creationId xmlns:a16="http://schemas.microsoft.com/office/drawing/2014/main" id="{8F5A9CC3-C3E7-44A2-9AED-3EAA5464F1E3}"/>
+                <a16:creationId xmlns:a16="http://schemas.microsoft.com/office/drawing/2014/main" id="{5A252FA1-089C-43C6-8FFB-B8138642DE5D}"/>
               </a:ext>
             </a:extLst>
           </p:cNvPr>
@@ -6749,7 +6853,7 @@
           <p:cNvPr id="16" name="">
             <a:extLst xmlns:a="http://schemas.openxmlformats.org/drawingml/2006/main">
               <a:ext uri="{FF2B5EF4-FFF2-40B4-BE49-F238E27FC236}">
-                <a16:creationId xmlns:a16="http://schemas.microsoft.com/office/drawing/2014/main" id="{17E3CBF4-DAC4-47E2-8A49-81F8A39015EA}"/>
+                <a16:creationId xmlns:a16="http://schemas.microsoft.com/office/drawing/2014/main" id="{6F1CD9BC-67A5-4BAA-AFC0-8396B440BA4F}"/>
               </a:ext>
             </a:extLst>
           </p:cNvPr>
@@ -6810,7 +6914,7 @@
           <p:cNvPr id="17" name="">
             <a:extLst xmlns:a="http://schemas.openxmlformats.org/drawingml/2006/main">
               <a:ext uri="{FF2B5EF4-FFF2-40B4-BE49-F238E27FC236}">
-                <a16:creationId xmlns:a16="http://schemas.microsoft.com/office/drawing/2014/main" id="{0E88831E-FE2D-44BD-BDEC-9AAB0B1D157B}"/>
+                <a16:creationId xmlns:a16="http://schemas.microsoft.com/office/drawing/2014/main" id="{B1902DD1-A709-49E2-9267-DB6EE34208F5}"/>
               </a:ext>
             </a:extLst>
           </p:cNvPr>
@@ -6871,7 +6975,7 @@
           <p:cNvPr id="18" name="">
             <a:extLst xmlns:a="http://schemas.openxmlformats.org/drawingml/2006/main">
               <a:ext uri="{FF2B5EF4-FFF2-40B4-BE49-F238E27FC236}">
-                <a16:creationId xmlns:a16="http://schemas.microsoft.com/office/drawing/2014/main" id="{26C7E08C-5D5A-40E7-A2BD-7DAE1F09CDE1}"/>
+                <a16:creationId xmlns:a16="http://schemas.microsoft.com/office/drawing/2014/main" id="{03AE86DF-5611-4A5E-8BCB-6D67C833FB2B}"/>
               </a:ext>
             </a:extLst>
           </p:cNvPr>
@@ -6932,7 +7036,7 @@
           <p:cNvPr id="19" name="">
             <a:extLst xmlns:a="http://schemas.openxmlformats.org/drawingml/2006/main">
               <a:ext uri="{FF2B5EF4-FFF2-40B4-BE49-F238E27FC236}">
-                <a16:creationId xmlns:a16="http://schemas.microsoft.com/office/drawing/2014/main" id="{47B8AEE9-622A-4472-AD97-92C8EF1CCC8F}"/>
+                <a16:creationId xmlns:a16="http://schemas.microsoft.com/office/drawing/2014/main" id="{611EBEF0-7041-4694-B09C-C0CD08A5C665}"/>
               </a:ext>
             </a:extLst>
           </p:cNvPr>
@@ -7116,7 +7220,7 @@
           <p:cNvPr id="24" name="">
             <a:extLst xmlns:a="http://schemas.openxmlformats.org/drawingml/2006/main">
               <a:ext uri="{FF2B5EF4-FFF2-40B4-BE49-F238E27FC236}">
-                <a16:creationId xmlns:a16="http://schemas.microsoft.com/office/drawing/2014/main" id="{CB1D46DF-B35C-409C-B719-73EA5FF224CE}"/>
+                <a16:creationId xmlns:a16="http://schemas.microsoft.com/office/drawing/2014/main" id="{7F07CD88-5BF9-4D9F-A10F-87DA9F7DBFB3}"/>
               </a:ext>
             </a:extLst>
           </p:cNvPr>
@@ -7173,7 +7277,7 @@
           <p:cNvPr id="25" name="">
             <a:extLst xmlns:a="http://schemas.openxmlformats.org/drawingml/2006/main">
               <a:ext uri="{FF2B5EF4-FFF2-40B4-BE49-F238E27FC236}">
-                <a16:creationId xmlns:a16="http://schemas.microsoft.com/office/drawing/2014/main" id="{5BE4D59C-3C1C-4586-A37B-7673258FB3CD}"/>
+                <a16:creationId xmlns:a16="http://schemas.microsoft.com/office/drawing/2014/main" id="{E3BB0157-E565-44F7-BBE2-464AB4C5ABB4}"/>
               </a:ext>
             </a:extLst>
           </p:cNvPr>
@@ -12674,7 +12778,7 @@
                           <a:ea typeface="Arial"/>
                           <a:cs typeface="Arial"/>
                         </a:rPr>
-                        <a:t>Local workflow scenarios</a:t>
+                        <a:t>Hackathon achievement</a:t>
                       </a:r>
                     </a:p>
                   </a:txBody>
@@ -12700,7 +12804,7 @@
                           <a:ea typeface="Arial"/>
                           <a:cs typeface="Arial"/>
                         </a:rPr>
-                        <a:t>Illustrative examples; validate with representative users</a:t>
+                        <a:t>Team reports a win; attach event details and award reference</a:t>
                       </a:r>
                     </a:p>
                   </a:txBody>

</xml_diff>